<commit_message>
AI Hub profiles for X2 Elite and X Elite, README and deck numbers, offline Whisper tokenizer
</commit_message>
<xml_diff>
--- a/docs/deck/Sahaay_Pitch.pptx
+++ b/docs/deck/Sahaay_Pitch.pptx
@@ -9395,8 +9395,8 @@
         </p:nvSpPr>
         <p:spPr>
           <a:xfrm>
-            <a:off x="548640" y="5120640"/>
-            <a:ext cx="6949440" cy="1097280"/>
+            <a:off x="548640" y="5074920"/>
+            <a:ext cx="6949440" cy="1280160"/>
           </a:xfrm>
           <a:prstGeom prst="rect">
             <a:avLst/>
@@ -9417,7 +9417,31 @@
                 </a:solidFill>
                 <a:latin typeface="Segoe UI"/>
               </a:rPr>
-              <a:t>AI Hub profiling on reference devices: face detector 0.4 ms (145/145 ops on NPU), face mesh 0.2 ms (105/105), Whisper decoder 2.4 ms (975/975) on Snapdragon X2 Elite CRD; X Elite CRD numbers in benchmarks/.</a:t>
+              <a:t>Qualcomm AI Hub profiling, every op on the NPU (job links in benchmarks/aihub_profiles.md):</a:t>
+            </a:r>
+          </a:p>
+          <a:p>
+            <a:pPr algn="l"/>
+            <a:r>
+              <a:rPr sz="1100" b="0">
+                <a:solidFill>
+                  <a:srgbClr val="8A97A6"/>
+                </a:solidFill>
+                <a:latin typeface="Segoe UI"/>
+              </a:rPr>
+              <a:t>Snapdragon X2 Elite CRD: face detector 0.4 ms, face mesh 0.2 ms, Whisper encoder 21.5 ms, decoder 2.4 ms/token.</a:t>
+            </a:r>
+          </a:p>
+          <a:p>
+            <a:pPr algn="l"/>
+            <a:r>
+              <a:rPr sz="1100" b="0">
+                <a:solidFill>
+                  <a:srgbClr val="8A97A6"/>
+                </a:solidFill>
+                <a:latin typeface="Segoe UI"/>
+              </a:rPr>
+              <a:t>Snapdragon X Elite CRD (HP OmniBook): face detector 0.7 ms, face mesh 0.3 ms, Whisper encoder 45.4 ms, decoder 3.7 ms/token.</a:t>
             </a:r>
           </a:p>
         </p:txBody>

</xml_diff>

<commit_message>
Measured benchmarks (results.md/json); README, deck and description use measured numbers and honest memory figures
</commit_message>
<xml_diff>
--- a/docs/deck/Sahaay_Pitch.pptx
+++ b/docs/deck/Sahaay_Pitch.pptx
@@ -6124,7 +6124,7 @@
                 </a:solidFill>
                 <a:latin typeface="Segoe UI"/>
               </a:rPr>
-              <a:t>encoder 25 ms, decoder 3 ms/token</a:t>
+              <a:t>encoder 21 ms, decoder 2.7 ms/token</a:t>
             </a:r>
           </a:p>
         </p:txBody>
@@ -6190,7 +6190,7 @@
                 </a:solidFill>
                 <a:latin typeface="Segoe UI"/>
               </a:rPr>
-              <a:t>screen list + speech to JSON tool calls, 33 tok/s</a:t>
+              <a:t>screen list + speech to JSON tool calls, 31 tok/s</a:t>
             </a:r>
           </a:p>
         </p:txBody>
@@ -6256,7 +6256,7 @@
                 </a:solidFill>
                 <a:latin typeface="Segoe UI"/>
               </a:rPr>
-              <a:t>describes screen and camera, 30 tok/s</a:t>
+              <a:t>describes screen and camera, 25 tok/s</a:t>
             </a:r>
           </a:p>
         </p:txBody>
@@ -6718,7 +6718,7 @@
                 </a:solidFill>
                 <a:latin typeface="Segoe UI"/>
               </a:rPr>
-              <a:t>16x real time</a:t>
+              <a:t>23x real time, CPU</a:t>
             </a:r>
           </a:p>
         </p:txBody>
@@ -8540,7 +8540,7 @@
                           </a:solidFill>
                           <a:latin typeface="Segoe UI"/>
                         </a:rPr>
-                        <a:t>2.97 ms</a:t>
+                        <a:t>2.75 ms</a:t>
                       </a:r>
                     </a:p>
                   </a:txBody>
@@ -8562,7 +8562,7 @@
                           </a:solidFill>
                           <a:latin typeface="Segoe UI"/>
                         </a:rPr>
-                        <a:t>0.42 ms</a:t>
+                        <a:t>0.43 ms</a:t>
                       </a:r>
                     </a:p>
                   </a:txBody>
@@ -8584,7 +8584,7 @@
                           </a:solidFill>
                           <a:latin typeface="Segoe UI"/>
                         </a:rPr>
-                        <a:t>7x</a:t>
+                        <a:t>6x</a:t>
                       </a:r>
                     </a:p>
                   </a:txBody>
@@ -8630,7 +8630,7 @@
                           </a:solidFill>
                           <a:latin typeface="Segoe UI"/>
                         </a:rPr>
-                        <a:t>1.01 ms</a:t>
+                        <a:t>0.87 ms</a:t>
                       </a:r>
                     </a:p>
                   </a:txBody>
@@ -8674,7 +8674,7 @@
                           </a:solidFill>
                           <a:latin typeface="Segoe UI"/>
                         </a:rPr>
-                        <a:t>6x</a:t>
+                        <a:t>5x</a:t>
                       </a:r>
                     </a:p>
                   </a:txBody>
@@ -8698,7 +8698,7 @@
                           </a:solidFill>
                           <a:latin typeface="Segoe UI"/>
                         </a:rPr>
-                        <a:t>Full face pipeline, live 720p</a:t>
+                        <a:t>Full face pipeline, live 720p frame</a:t>
                       </a:r>
                     </a:p>
                   </a:txBody>
@@ -8720,7 +8720,7 @@
                           </a:solidFill>
                           <a:latin typeface="Segoe UI"/>
                         </a:rPr>
-                        <a:t/>
+                        <a:t>25.34 ms</a:t>
                       </a:r>
                     </a:p>
                   </a:txBody>
@@ -8742,7 +8742,7 @@
                           </a:solidFill>
                           <a:latin typeface="Segoe UI"/>
                         </a:rPr>
-                        <a:t>2.7 ms/frame</a:t>
+                        <a:t>2.74 ms/frame</a:t>
                       </a:r>
                     </a:p>
                   </a:txBody>
@@ -8764,7 +8764,7 @@
                           </a:solidFill>
                           <a:latin typeface="Segoe UI"/>
                         </a:rPr>
-                        <a:t>28 fps, camera-bound</a:t>
+                        <a:t>webcam delivers 28 fps</a:t>
                       </a:r>
                     </a:p>
                   </a:txBody>
@@ -8810,7 +8810,7 @@
                           </a:solidFill>
                           <a:latin typeface="Segoe UI"/>
                         </a:rPr>
-                        <a:t/>
+                        <a:t>n/a (QNN context)</a:t>
                       </a:r>
                     </a:p>
                   </a:txBody>
@@ -8832,7 +8832,7 @@
                           </a:solidFill>
                           <a:latin typeface="Segoe UI"/>
                         </a:rPr>
-                        <a:t>25 ms</a:t>
+                        <a:t>22 ms</a:t>
                       </a:r>
                     </a:p>
                   </a:txBody>
@@ -8900,7 +8900,7 @@
                           </a:solidFill>
                           <a:latin typeface="Segoe UI"/>
                         </a:rPr>
-                        <a:t/>
+                        <a:t>n/a</a:t>
                       </a:r>
                     </a:p>
                   </a:txBody>
@@ -8922,7 +8922,7 @@
                           </a:solidFill>
                           <a:latin typeface="Segoe UI"/>
                         </a:rPr>
-                        <a:t>3.0 ms/token</a:t>
+                        <a:t>2.7 ms/token</a:t>
                       </a:r>
                     </a:p>
                   </a:txBody>
@@ -8944,7 +8944,7 @@
                           </a:solidFill>
                           <a:latin typeface="Segoe UI"/>
                         </a:rPr>
-                        <a:t>a 6 s command in ~100 ms</a:t>
+                        <a:t>a 5.6 s command in 79 ms</a:t>
                       </a:r>
                     </a:p>
                   </a:txBody>
@@ -8968,7 +8968,7 @@
                           </a:solidFill>
                           <a:latin typeface="Segoe UI"/>
                         </a:rPr>
-                        <a:t>Qwen3-4B (GenieX)</a:t>
+                        <a:t>Qwen3-4B (GenieX), screen context</a:t>
                       </a:r>
                     </a:p>
                   </a:txBody>
@@ -9012,7 +9012,7 @@
                           </a:solidFill>
                           <a:latin typeface="Segoe UI"/>
                         </a:rPr>
-                        <a:t>60 ms to first token, 33 tok/s</a:t>
+                        <a:t>243 ms to first token, 30.9 tok/s</a:t>
                       </a:r>
                     </a:p>
                   </a:txBody>
@@ -9034,7 +9034,7 @@
                           </a:solidFill>
                           <a:latin typeface="Segoe UI"/>
                         </a:rPr>
-                        <a:t>loads in 8 s</a:t>
+                        <a:t>loads in 10.1 s</a:t>
                       </a:r>
                     </a:p>
                   </a:txBody>
@@ -9102,7 +9102,7 @@
                           </a:solidFill>
                           <a:latin typeface="Segoe UI"/>
                         </a:rPr>
-                        <a:t>280 ms to first token, 30 tok/s</a:t>
+                        <a:t>269 ms to first token, 25.3 tok/s</a:t>
                       </a:r>
                     </a:p>
                   </a:txBody>
@@ -9124,7 +9124,7 @@
                           </a:solidFill>
                           <a:latin typeface="Segoe UI"/>
                         </a:rPr>
-                        <a:t>2.3 s per description</a:t>
+                        <a:t>loads in 10.1 s</a:t>
                       </a:r>
                     </a:p>
                   </a:txBody>
@@ -9170,7 +9170,7 @@
                           </a:solidFill>
                           <a:latin typeface="Segoe UI"/>
                         </a:rPr>
-                        <a:t>230 ms</a:t>
+                        <a:t>167 ms</a:t>
                       </a:r>
                     </a:p>
                   </a:txBody>
@@ -9214,7 +9214,7 @@
                           </a:solidFill>
                           <a:latin typeface="Segoe UI"/>
                         </a:rPr>
-                        <a:t>16x real time</a:t>
+                        <a:t>23x real time</a:t>
                       </a:r>
                     </a:p>
                   </a:txBody>
@@ -9684,7 +9684,7 @@
                 </a:solidFill>
                 <a:latin typeface="Segoe UI"/>
               </a:rPr>
-              <a:t>  including HP OmniBook X, 5, 3, Ultra and EliteBook Ultra. 16 GB RAM recommended; --no-vlm on tighter machines.</a:t>
+              <a:t>  including HP OmniBook X, 5, 3, Ultra and EliteBook Ultra. Hands-free mode within 16 GB; both generative models resident on 32 GB (LLM 5.4 GB, VLM 6.1 GB measured), or the 2B vision model on 16 GB.</a:t>
             </a:r>
           </a:p>
           <a:p>
@@ -10448,7 +10448,7 @@
                 </a:solidFill>
                 <a:latin typeface="Segoe UI"/>
               </a:rPr>
-              <a:t>  built within 45 TOPS and 16 GB; on the 80 TOPS X2 the same code runs bigger vision models and adds gaze.</a:t>
+              <a:t>  built for 45 TOPS; hands-free mode fits 16 GB, the full stack 32 GB; on the 80 TOPS X2 the same code runs bigger vision models and adds gaze.</a:t>
             </a:r>
           </a:p>
         </p:txBody>

</xml_diff>